<commit_message>
Add verified history lines to credit bureaus deck
Co-authored-by: arena-agent <297053741+arena-agent@users.noreply.github.com>
</commit_message>
<xml_diff>
--- a/travaux-groupe/Money-Banking/bonus_credit_scoring/output/BONUS-2-CREDIT-BUREAUS-TEAM-5.pptx
+++ b/travaux-groupe/Money-Banking/bonus_credit_scoring/output/BONUS-2-CREDIT-BUREAUS-TEAM-5.pptx
@@ -7198,13 +7198,52 @@
       </p:pic>
       <p:sp>
         <p:nvSpPr>
-          <p:cNvPr id="10" name="Rectangle 9"/>
+          <p:cNvPr id="10" name="TextBox 9"/>
+          <p:cNvSpPr txBox="1"/>
+          <p:nvPr/>
+        </p:nvSpPr>
+        <p:spPr>
+          <a:xfrm>
+            <a:off x="822959" y="2971800"/>
+            <a:ext cx="2606040" cy="182880"/>
+          </a:xfrm>
+          <a:prstGeom prst="rect">
+            <a:avLst/>
+          </a:prstGeom>
+          <a:noFill/>
+        </p:spPr>
+        <p:txBody>
+          <a:bodyPr wrap="square" lIns="36576" rIns="36576" tIns="36576" bIns="36576" anchor="t">
+            <a:spAutoFit/>
+          </a:bodyPr>
+          <a:lstStyle/>
+          <a:p>
+            <a:pPr algn="l">
+              <a:spcAft>
+                <a:spcPts val="0"/>
+              </a:spcAft>
+            </a:pPr>
+            <a:r>
+              <a:rPr sz="819" b="1" i="0">
+                <a:solidFill>
+                  <a:srgbClr val="9B1C3F"/>
+                </a:solidFill>
+                <a:latin typeface="Aptos"/>
+              </a:rPr>
+              <a:t>Founded 1899</a:t>
+            </a:r>
+          </a:p>
+        </p:txBody>
+      </p:sp>
+      <p:sp>
+        <p:nvSpPr>
+          <p:cNvPr id="11" name="Rectangle 10"/>
           <p:cNvSpPr/>
           <p:nvPr/>
         </p:nvSpPr>
         <p:spPr>
           <a:xfrm>
-            <a:off x="822959" y="3182112"/>
+            <a:off x="822959" y="3246120"/>
             <a:ext cx="2670048" cy="10972"/>
           </a:xfrm>
           <a:prstGeom prst="rect">
@@ -7241,13 +7280,13 @@
       </p:sp>
       <p:sp>
         <p:nvSpPr>
-          <p:cNvPr id="11" name="TextBox 10"/>
+          <p:cNvPr id="12" name="TextBox 11"/>
           <p:cNvSpPr txBox="1"/>
           <p:nvPr/>
         </p:nvSpPr>
         <p:spPr>
           <a:xfrm>
-            <a:off x="822959" y="3383280"/>
+            <a:off x="822959" y="3438144"/>
             <a:ext cx="2560320" cy="201168"/>
           </a:xfrm>
           <a:prstGeom prst="rect">
@@ -7280,13 +7319,13 @@
       </p:sp>
       <p:sp>
         <p:nvSpPr>
-          <p:cNvPr id="12" name="TextBox 11"/>
+          <p:cNvPr id="13" name="TextBox 12"/>
           <p:cNvSpPr txBox="1"/>
           <p:nvPr/>
         </p:nvSpPr>
         <p:spPr>
           <a:xfrm>
-            <a:off x="822959" y="3657600"/>
+            <a:off x="822959" y="3694176"/>
             <a:ext cx="2596896" cy="566928"/>
           </a:xfrm>
           <a:prstGeom prst="rect">
@@ -7320,7 +7359,7 @@
       </p:sp>
       <p:sp>
         <p:nvSpPr>
-          <p:cNvPr id="13" name="TextBox 12"/>
+          <p:cNvPr id="14" name="TextBox 13"/>
           <p:cNvSpPr txBox="1"/>
           <p:nvPr/>
         </p:nvSpPr>
@@ -7359,7 +7398,7 @@
       </p:sp>
       <p:sp>
         <p:nvSpPr>
-          <p:cNvPr id="14" name="TextBox 13"/>
+          <p:cNvPr id="15" name="TextBox 14"/>
           <p:cNvSpPr txBox="1"/>
           <p:nvPr/>
         </p:nvSpPr>
@@ -7439,7 +7478,7 @@
       </p:sp>
       <p:sp>
         <p:nvSpPr>
-          <p:cNvPr id="15" name="Rounded Rectangle 14"/>
+          <p:cNvPr id="16" name="Rounded Rectangle 15"/>
           <p:cNvSpPr/>
           <p:nvPr/>
         </p:nvSpPr>
@@ -7484,7 +7523,7 @@
       </p:sp>
       <p:pic>
         <p:nvPicPr>
-          <p:cNvPr id="16" name="Picture 15" descr="experian_logo.png"/>
+          <p:cNvPr id="17" name="Picture 16" descr="experian_logo.png"/>
           <p:cNvPicPr>
             <a:picLocks noChangeAspect="1"/>
           </p:cNvPicPr>
@@ -7508,13 +7547,52 @@
       </p:pic>
       <p:sp>
         <p:nvSpPr>
-          <p:cNvPr id="17" name="Rectangle 16"/>
+          <p:cNvPr id="18" name="TextBox 17"/>
+          <p:cNvSpPr txBox="1"/>
+          <p:nvPr/>
+        </p:nvSpPr>
+        <p:spPr>
+          <a:xfrm>
+            <a:off x="4370832" y="2971800"/>
+            <a:ext cx="2606040" cy="182880"/>
+          </a:xfrm>
+          <a:prstGeom prst="rect">
+            <a:avLst/>
+          </a:prstGeom>
+          <a:noFill/>
+        </p:spPr>
+        <p:txBody>
+          <a:bodyPr wrap="square" lIns="36576" rIns="36576" tIns="36576" bIns="36576" anchor="t">
+            <a:spAutoFit/>
+          </a:bodyPr>
+          <a:lstStyle/>
+          <a:p>
+            <a:pPr algn="l">
+              <a:spcAft>
+                <a:spcPts val="0"/>
+              </a:spcAft>
+            </a:pPr>
+            <a:r>
+              <a:rPr sz="819" b="1" i="0">
+                <a:solidFill>
+                  <a:srgbClr val="2F68A7"/>
+                </a:solidFill>
+                <a:latin typeface="Aptos"/>
+              </a:rPr>
+              <a:t>Current group established 1996</a:t>
+            </a:r>
+          </a:p>
+        </p:txBody>
+      </p:sp>
+      <p:sp>
+        <p:nvSpPr>
+          <p:cNvPr id="19" name="Rectangle 18"/>
           <p:cNvSpPr/>
           <p:nvPr/>
         </p:nvSpPr>
         <p:spPr>
           <a:xfrm>
-            <a:off x="4370832" y="3182112"/>
+            <a:off x="4370832" y="3246120"/>
             <a:ext cx="2670048" cy="10972"/>
           </a:xfrm>
           <a:prstGeom prst="rect">
@@ -7551,13 +7629,13 @@
       </p:sp>
       <p:sp>
         <p:nvSpPr>
-          <p:cNvPr id="18" name="TextBox 17"/>
+          <p:cNvPr id="20" name="TextBox 19"/>
           <p:cNvSpPr txBox="1"/>
           <p:nvPr/>
         </p:nvSpPr>
         <p:spPr>
           <a:xfrm>
-            <a:off x="4370832" y="3383280"/>
+            <a:off x="4370832" y="3438144"/>
             <a:ext cx="2560320" cy="201168"/>
           </a:xfrm>
           <a:prstGeom prst="rect">
@@ -7590,13 +7668,13 @@
       </p:sp>
       <p:sp>
         <p:nvSpPr>
-          <p:cNvPr id="19" name="TextBox 18"/>
+          <p:cNvPr id="21" name="TextBox 20"/>
           <p:cNvSpPr txBox="1"/>
           <p:nvPr/>
         </p:nvSpPr>
         <p:spPr>
           <a:xfrm>
-            <a:off x="4370832" y="3657600"/>
+            <a:off x="4370832" y="3694176"/>
             <a:ext cx="2596896" cy="566928"/>
           </a:xfrm>
           <a:prstGeom prst="rect">
@@ -7630,7 +7708,7 @@
       </p:sp>
       <p:sp>
         <p:nvSpPr>
-          <p:cNvPr id="20" name="TextBox 19"/>
+          <p:cNvPr id="22" name="TextBox 21"/>
           <p:cNvSpPr txBox="1"/>
           <p:nvPr/>
         </p:nvSpPr>
@@ -7669,7 +7747,7 @@
       </p:sp>
       <p:sp>
         <p:nvSpPr>
-          <p:cNvPr id="21" name="TextBox 20"/>
+          <p:cNvPr id="23" name="TextBox 22"/>
           <p:cNvSpPr txBox="1"/>
           <p:nvPr/>
         </p:nvSpPr>
@@ -7749,7 +7827,7 @@
       </p:sp>
       <p:sp>
         <p:nvSpPr>
-          <p:cNvPr id="22" name="Rounded Rectangle 21"/>
+          <p:cNvPr id="24" name="Rounded Rectangle 23"/>
           <p:cNvSpPr/>
           <p:nvPr/>
         </p:nvSpPr>
@@ -7794,7 +7872,7 @@
       </p:sp>
       <p:pic>
         <p:nvPicPr>
-          <p:cNvPr id="23" name="Picture 22" descr="transunion_logo.png"/>
+          <p:cNvPr id="25" name="Picture 24" descr="transunion_logo.png"/>
           <p:cNvPicPr>
             <a:picLocks noChangeAspect="1"/>
           </p:cNvPicPr>
@@ -7818,13 +7896,52 @@
       </p:pic>
       <p:sp>
         <p:nvSpPr>
-          <p:cNvPr id="24" name="Rectangle 23"/>
+          <p:cNvPr id="26" name="TextBox 25"/>
+          <p:cNvSpPr txBox="1"/>
+          <p:nvPr/>
+        </p:nvSpPr>
+        <p:spPr>
+          <a:xfrm>
+            <a:off x="7918704" y="2971800"/>
+            <a:ext cx="2606040" cy="182880"/>
+          </a:xfrm>
+          <a:prstGeom prst="rect">
+            <a:avLst/>
+          </a:prstGeom>
+          <a:noFill/>
+        </p:spPr>
+        <p:txBody>
+          <a:bodyPr wrap="square" lIns="36576" rIns="36576" tIns="36576" bIns="36576" anchor="t">
+            <a:spAutoFit/>
+          </a:bodyPr>
+          <a:lstStyle/>
+          <a:p>
+            <a:pPr algn="l">
+              <a:spcAft>
+                <a:spcPts val="0"/>
+              </a:spcAft>
+            </a:pPr>
+            <a:r>
+              <a:rPr sz="819" b="1" i="0">
+                <a:solidFill>
+                  <a:srgbClr val="08A5BE"/>
+                </a:solidFill>
+                <a:latin typeface="Aptos"/>
+              </a:rPr>
+              <a:t>Founded 1968</a:t>
+            </a:r>
+          </a:p>
+        </p:txBody>
+      </p:sp>
+      <p:sp>
+        <p:nvSpPr>
+          <p:cNvPr id="27" name="Rectangle 26"/>
           <p:cNvSpPr/>
           <p:nvPr/>
         </p:nvSpPr>
         <p:spPr>
           <a:xfrm>
-            <a:off x="7918704" y="3182112"/>
+            <a:off x="7918704" y="3246120"/>
             <a:ext cx="2670048" cy="10972"/>
           </a:xfrm>
           <a:prstGeom prst="rect">
@@ -7861,13 +7978,13 @@
       </p:sp>
       <p:sp>
         <p:nvSpPr>
-          <p:cNvPr id="25" name="TextBox 24"/>
+          <p:cNvPr id="28" name="TextBox 27"/>
           <p:cNvSpPr txBox="1"/>
           <p:nvPr/>
         </p:nvSpPr>
         <p:spPr>
           <a:xfrm>
-            <a:off x="7918704" y="3383280"/>
+            <a:off x="7918704" y="3438144"/>
             <a:ext cx="2560320" cy="201168"/>
           </a:xfrm>
           <a:prstGeom prst="rect">
@@ -7900,13 +8017,13 @@
       </p:sp>
       <p:sp>
         <p:nvSpPr>
-          <p:cNvPr id="26" name="TextBox 25"/>
+          <p:cNvPr id="29" name="TextBox 28"/>
           <p:cNvSpPr txBox="1"/>
           <p:nvPr/>
         </p:nvSpPr>
         <p:spPr>
           <a:xfrm>
-            <a:off x="7918704" y="3657600"/>
+            <a:off x="7918704" y="3694176"/>
             <a:ext cx="2596896" cy="566928"/>
           </a:xfrm>
           <a:prstGeom prst="rect">
@@ -7940,7 +8057,7 @@
       </p:sp>
       <p:sp>
         <p:nvSpPr>
-          <p:cNvPr id="27" name="TextBox 26"/>
+          <p:cNvPr id="30" name="TextBox 29"/>
           <p:cNvSpPr txBox="1"/>
           <p:nvPr/>
         </p:nvSpPr>
@@ -7979,7 +8096,7 @@
       </p:sp>
       <p:sp>
         <p:nvSpPr>
-          <p:cNvPr id="28" name="TextBox 27"/>
+          <p:cNvPr id="31" name="TextBox 30"/>
           <p:cNvSpPr txBox="1"/>
           <p:nvPr/>
         </p:nvSpPr>
@@ -8059,7 +8176,7 @@
       </p:sp>
       <p:sp>
         <p:nvSpPr>
-          <p:cNvPr id="29" name="Rectangle 28"/>
+          <p:cNvPr id="32" name="Rectangle 31"/>
           <p:cNvSpPr/>
           <p:nvPr/>
         </p:nvSpPr>
@@ -8102,7 +8219,7 @@
       </p:sp>
       <p:sp>
         <p:nvSpPr>
-          <p:cNvPr id="30" name="TextBox 29"/>
+          <p:cNvPr id="33" name="TextBox 32"/>
           <p:cNvSpPr txBox="1"/>
           <p:nvPr/>
         </p:nvSpPr>
@@ -8134,14 +8251,14 @@
                 </a:solidFill>
                 <a:latin typeface="Aptos"/>
               </a:rPr>
-              <a:t>Sources: official Equifax, Experian and TransUnion pages listed on slide 6. Positioning language is paraphrased unless directly quoted by the source.</a:t>
-            </a:r>
-          </a:p>
-        </p:txBody>
-      </p:sp>
-      <p:sp>
-        <p:nvSpPr>
-          <p:cNvPr id="31" name="TextBox 30"/>
+              <a:t>History: official company information pages listed on slide 6. Positioning is paraphrased and is not a performance ranking.</a:t>
+            </a:r>
+          </a:p>
+        </p:txBody>
+      </p:sp>
+      <p:sp>
+        <p:nvSpPr>
+          <p:cNvPr id="34" name="TextBox 33"/>
           <p:cNvSpPr txBox="1"/>
           <p:nvPr/>
         </p:nvSpPr>
@@ -9599,7 +9716,7 @@
               </a:defRPr>
             </a:pPr>
             <a:r>
-              <a:t>Equifax: https://www.equifax.com/about-equifax/ | https://www.equifax.com/personal/credit-report-services/</a:t>
+              <a:t>Equifax: https://www.equifax.com/about-equifax/ | https://investor.equifax.com/company-information</a:t>
             </a:r>
           </a:p>
           <a:p>
@@ -9618,7 +9735,45 @@
               </a:defRPr>
             </a:pPr>
             <a:r>
-              <a:t>Experian: https://www.experianplc.com/about-us/ | https://www.experian.com/consumer-information/</a:t>
+              <a:t>Equifax services: https://www.equifax.com/personal/credit-report-services/</a:t>
+            </a:r>
+          </a:p>
+          <a:p>
+            <a:pPr>
+              <a:lnSpc>
+                <a:spcPct val="88000"/>
+              </a:lnSpc>
+              <a:spcAft>
+                <a:spcPts val="500"/>
+              </a:spcAft>
+              <a:defRPr sz="610">
+                <a:solidFill>
+                  <a:srgbClr val="667085"/>
+                </a:solidFill>
+                <a:latin typeface="Aptos"/>
+              </a:defRPr>
+            </a:pPr>
+            <a:r>
+              <a:t>Experian: https://www.experianplc.com/about-us/ | https://www.experian.com/corporate/principal-businesses</a:t>
+            </a:r>
+          </a:p>
+          <a:p>
+            <a:pPr>
+              <a:lnSpc>
+                <a:spcPct val="88000"/>
+              </a:lnSpc>
+              <a:spcAft>
+                <a:spcPts val="500"/>
+              </a:spcAft>
+              <a:defRPr sz="610">
+                <a:solidFill>
+                  <a:srgbClr val="667085"/>
+                </a:solidFill>
+                <a:latin typeface="Aptos"/>
+              </a:defRPr>
+            </a:pPr>
+            <a:r>
+              <a:t>Experian consumer information: https://www.experian.com/consumer-information/</a:t>
             </a:r>
           </a:p>
           <a:p>

</xml_diff>